<commit_message>
Updated PPT with app screenshots and live deployment URL
</commit_message>
<xml_diff>
--- a/Crop_Recommendation.pptx
+++ b/Crop_Recommendation.pptx
@@ -18,6 +18,7 @@
     <p:sldId id="263" r:id="rId11"/>
     <p:sldId id="264" r:id="rId12"/>
     <p:sldId id="265" r:id="rId13"/>
+    <p:sldId id="268" r:id="rId18"/>
     <p:sldId id="267" r:id="rId14"/>
   </p:sldIdLst>
   <p:sldSz cx="9144000" cy="5143500" type="screen16x9"/>
@@ -4733,6 +4734,924 @@
               <a:t>Thank You  • </a:t>
             </a:r>
             <a:endParaRPr lang="en-US" sz="1200" dirty="0"/>
+          </a:p>
+        </p:txBody>
+      </p:sp>
+    </p:spTree>
+  </p:cSld>
+  <p:clrMapOvr>
+    <a:masterClrMapping/>
+  </p:clrMapOvr>
+</p:sld>
+</file>
+
+<file path=ppt/slides/slide12.xml><?xml version="1.0" encoding="utf-8"?>
+<p:sld xmlns:a="http://schemas.openxmlformats.org/drawingml/2006/main" xmlns:p="http://schemas.openxmlformats.org/presentationml/2006/main" xmlns:r="http://schemas.openxmlformats.org/officeDocument/2006/relationships">
+  <p:cSld>
+    <p:bg>
+      <p:bgPr>
+        <a:solidFill>
+          <a:srgbClr val="F4FAF6"/>
+        </a:solidFill>
+        <a:effectLst/>
+      </p:bgPr>
+    </p:bg>
+    <p:spTree>
+      <p:nvGrpSpPr>
+        <p:cNvPr id="1" name=""/>
+        <p:cNvGrpSpPr/>
+        <p:nvPr/>
+      </p:nvGrpSpPr>
+      <p:grpSpPr/>
+      <p:sp>
+        <p:nvSpPr>
+          <p:cNvPr id="2" name="TextBox 1"/>
+          <p:cNvSpPr txBox="1"/>
+          <p:nvPr/>
+        </p:nvSpPr>
+        <p:spPr>
+          <a:xfrm>
+            <a:off x="457200" y="164592"/>
+            <a:ext cx="8229600" cy="502920"/>
+          </a:xfrm>
+          <a:prstGeom prst="rect">
+            <a:avLst/>
+          </a:prstGeom>
+          <a:noFill/>
+        </p:spPr>
+        <p:txBody>
+          <a:bodyPr wrap="square">
+            <a:spAutoFit/>
+          </a:bodyPr>
+          <a:lstStyle/>
+          <a:p>
+            <a:pPr algn="l"/>
+            <a:r>
+              <a:rPr sz="2800" b="1" i="0">
+                <a:solidFill>
+                  <a:srgbClr val="1A3A2A"/>
+                </a:solidFill>
+              </a:rPr>
+              <a:t>Live Deployment — Streamlit App</a:t>
+            </a:r>
+          </a:p>
+        </p:txBody>
+      </p:sp>
+      <p:sp>
+        <p:nvSpPr>
+          <p:cNvPr id="3" name="Rectangle 2"/>
+          <p:cNvSpPr/>
+          <p:nvPr/>
+        </p:nvSpPr>
+        <p:spPr>
+          <a:xfrm>
+            <a:off x="365760" y="777240"/>
+            <a:ext cx="8412480" cy="438912"/>
+          </a:xfrm>
+          <a:prstGeom prst="rect">
+            <a:avLst/>
+          </a:prstGeom>
+          <a:solidFill>
+            <a:srgbClr val="D8F3DC"/>
+          </a:solidFill>
+          <a:ln>
+            <a:noFill/>
+          </a:ln>
+        </p:spPr>
+        <p:style>
+          <a:lnRef idx="1">
+            <a:schemeClr val="accent1"/>
+          </a:lnRef>
+          <a:fillRef idx="3">
+            <a:schemeClr val="accent1"/>
+          </a:fillRef>
+          <a:effectRef idx="2">
+            <a:schemeClr val="accent1"/>
+          </a:effectRef>
+          <a:fontRef idx="minor">
+            <a:schemeClr val="lt1"/>
+          </a:fontRef>
+        </p:style>
+        <p:txBody>
+          <a:bodyPr rtlCol="0" anchor="ctr"/>
+          <a:lstStyle/>
+          <a:p>
+            <a:pPr algn="ctr"/>
+          </a:p>
+        </p:txBody>
+      </p:sp>
+      <p:sp>
+        <p:nvSpPr>
+          <p:cNvPr id="4" name="TextBox 3"/>
+          <p:cNvSpPr txBox="1"/>
+          <p:nvPr/>
+        </p:nvSpPr>
+        <p:spPr>
+          <a:xfrm>
+            <a:off x="502920" y="804672"/>
+            <a:ext cx="1188720" cy="320040"/>
+          </a:xfrm>
+          <a:prstGeom prst="rect">
+            <a:avLst/>
+          </a:prstGeom>
+          <a:noFill/>
+        </p:spPr>
+        <p:txBody>
+          <a:bodyPr wrap="square">
+            <a:spAutoFit/>
+          </a:bodyPr>
+          <a:lstStyle/>
+          <a:p>
+            <a:pPr algn="l"/>
+            <a:r>
+              <a:rPr sz="1100" b="1" i="0">
+                <a:solidFill>
+                  <a:srgbClr val="2C6E49"/>
+                </a:solidFill>
+              </a:rPr>
+              <a:t>🌐  Live URL:</a:t>
+            </a:r>
+          </a:p>
+        </p:txBody>
+      </p:sp>
+      <p:sp>
+        <p:nvSpPr>
+          <p:cNvPr id="5" name="TextBox 4"/>
+          <p:cNvSpPr txBox="1"/>
+          <p:nvPr/>
+        </p:nvSpPr>
+        <p:spPr>
+          <a:xfrm>
+            <a:off x="1691640" y="804672"/>
+            <a:ext cx="6949440" cy="320040"/>
+          </a:xfrm>
+          <a:prstGeom prst="rect">
+            <a:avLst/>
+          </a:prstGeom>
+          <a:noFill/>
+        </p:spPr>
+        <p:txBody>
+          <a:bodyPr wrap="square">
+            <a:spAutoFit/>
+          </a:bodyPr>
+          <a:lstStyle/>
+          <a:p>
+            <a:pPr algn="l"/>
+            <a:r>
+              <a:rPr sz="1000" b="0" i="1">
+                <a:solidFill>
+                  <a:srgbClr val="1A3A2A"/>
+                </a:solidFill>
+              </a:rPr>
+              <a:t>https://crop-recommendation-system-using-soil-and-climate-data-hgfcbtd.streamlit.app/</a:t>
+            </a:r>
+          </a:p>
+        </p:txBody>
+      </p:sp>
+      <p:pic>
+        <p:nvPicPr>
+          <p:cNvPr id="6" name="Picture 5" descr="Screenshot_2026-05-16_185529.png"/>
+          <p:cNvPicPr>
+            <a:picLocks noChangeAspect="1"/>
+          </p:cNvPicPr>
+          <p:nvPr/>
+        </p:nvPicPr>
+        <p:blipFill>
+          <a:blip r:embed="rId2"/>
+          <a:stretch>
+            <a:fillRect/>
+          </a:stretch>
+        </p:blipFill>
+        <p:spPr>
+          <a:xfrm>
+            <a:off x="365760" y="1298448"/>
+            <a:ext cx="4114800" cy="2560320"/>
+          </a:xfrm>
+          <a:prstGeom prst="rect">
+            <a:avLst/>
+          </a:prstGeom>
+        </p:spPr>
+      </p:pic>
+      <p:pic>
+        <p:nvPicPr>
+          <p:cNvPr id="7" name="Picture 6" descr="Screenshot_2026-05-16_185815.png"/>
+          <p:cNvPicPr>
+            <a:picLocks noChangeAspect="1"/>
+          </p:cNvPicPr>
+          <p:nvPr/>
+        </p:nvPicPr>
+        <p:blipFill>
+          <a:blip r:embed="rId3"/>
+          <a:stretch>
+            <a:fillRect/>
+          </a:stretch>
+        </p:blipFill>
+        <p:spPr>
+          <a:xfrm>
+            <a:off x="4663440" y="1298448"/>
+            <a:ext cx="4114800" cy="1234440"/>
+          </a:xfrm>
+          <a:prstGeom prst="rect">
+            <a:avLst/>
+          </a:prstGeom>
+        </p:spPr>
+      </p:pic>
+      <p:pic>
+        <p:nvPicPr>
+          <p:cNvPr id="8" name="Picture 7" descr="Screenshot_2026-05-16_185433.png"/>
+          <p:cNvPicPr>
+            <a:picLocks noChangeAspect="1"/>
+          </p:cNvPicPr>
+          <p:nvPr/>
+        </p:nvPicPr>
+        <p:blipFill>
+          <a:blip r:embed="rId4"/>
+          <a:stretch>
+            <a:fillRect/>
+          </a:stretch>
+        </p:blipFill>
+        <p:spPr>
+          <a:xfrm>
+            <a:off x="4663440" y="2606040"/>
+            <a:ext cx="4114800" cy="1252728"/>
+          </a:xfrm>
+          <a:prstGeom prst="rect">
+            <a:avLst/>
+          </a:prstGeom>
+        </p:spPr>
+      </p:pic>
+      <p:sp>
+        <p:nvSpPr>
+          <p:cNvPr id="9" name="Rectangle 8"/>
+          <p:cNvSpPr/>
+          <p:nvPr/>
+        </p:nvSpPr>
+        <p:spPr>
+          <a:xfrm>
+            <a:off x="365760" y="3913632"/>
+            <a:ext cx="4114800" cy="237744"/>
+          </a:xfrm>
+          <a:prstGeom prst="rect">
+            <a:avLst/>
+          </a:prstGeom>
+          <a:solidFill>
+            <a:srgbClr val="2C6E49"/>
+          </a:solidFill>
+          <a:ln>
+            <a:noFill/>
+          </a:ln>
+        </p:spPr>
+        <p:style>
+          <a:lnRef idx="1">
+            <a:schemeClr val="accent1"/>
+          </a:lnRef>
+          <a:fillRef idx="3">
+            <a:schemeClr val="accent1"/>
+          </a:fillRef>
+          <a:effectRef idx="2">
+            <a:schemeClr val="accent1"/>
+          </a:effectRef>
+          <a:fontRef idx="minor">
+            <a:schemeClr val="lt1"/>
+          </a:fontRef>
+        </p:style>
+        <p:txBody>
+          <a:bodyPr rtlCol="0" anchor="ctr"/>
+          <a:lstStyle/>
+          <a:p>
+            <a:pPr algn="ctr"/>
+          </a:p>
+        </p:txBody>
+      </p:sp>
+      <p:sp>
+        <p:nvSpPr>
+          <p:cNvPr id="10" name="TextBox 9"/>
+          <p:cNvSpPr txBox="1"/>
+          <p:nvPr/>
+        </p:nvSpPr>
+        <p:spPr>
+          <a:xfrm>
+            <a:off x="457200" y="3918204"/>
+            <a:ext cx="3931920" cy="219456"/>
+          </a:xfrm>
+          <a:prstGeom prst="rect">
+            <a:avLst/>
+          </a:prstGeom>
+          <a:noFill/>
+        </p:spPr>
+        <p:txBody>
+          <a:bodyPr wrap="square">
+            <a:spAutoFit/>
+          </a:bodyPr>
+          <a:lstStyle/>
+          <a:p>
+            <a:pPr algn="ctr"/>
+            <a:r>
+              <a:rPr sz="900" b="1" i="0">
+                <a:solidFill>
+                  <a:srgbClr val="FFFFFF"/>
+                </a:solidFill>
+              </a:rPr>
+              <a:t>CropSense — App Home Interface</a:t>
+            </a:r>
+          </a:p>
+        </p:txBody>
+      </p:sp>
+      <p:sp>
+        <p:nvSpPr>
+          <p:cNvPr id="11" name="Rectangle 10"/>
+          <p:cNvSpPr/>
+          <p:nvPr/>
+        </p:nvSpPr>
+        <p:spPr>
+          <a:xfrm>
+            <a:off x="4663440" y="3913632"/>
+            <a:ext cx="4114800" cy="237744"/>
+          </a:xfrm>
+          <a:prstGeom prst="rect">
+            <a:avLst/>
+          </a:prstGeom>
+          <a:solidFill>
+            <a:srgbClr val="4A9E6B"/>
+          </a:solidFill>
+          <a:ln>
+            <a:noFill/>
+          </a:ln>
+        </p:spPr>
+        <p:style>
+          <a:lnRef idx="1">
+            <a:schemeClr val="accent1"/>
+          </a:lnRef>
+          <a:fillRef idx="3">
+            <a:schemeClr val="accent1"/>
+          </a:fillRef>
+          <a:effectRef idx="2">
+            <a:schemeClr val="accent1"/>
+          </a:effectRef>
+          <a:fontRef idx="minor">
+            <a:schemeClr val="lt1"/>
+          </a:fontRef>
+        </p:style>
+        <p:txBody>
+          <a:bodyPr rtlCol="0" anchor="ctr"/>
+          <a:lstStyle/>
+          <a:p>
+            <a:pPr algn="ctr"/>
+          </a:p>
+        </p:txBody>
+      </p:sp>
+      <p:sp>
+        <p:nvSpPr>
+          <p:cNvPr id="12" name="TextBox 11"/>
+          <p:cNvSpPr txBox="1"/>
+          <p:nvPr/>
+        </p:nvSpPr>
+        <p:spPr>
+          <a:xfrm>
+            <a:off x="4754880" y="3918204"/>
+            <a:ext cx="3931920" cy="219456"/>
+          </a:xfrm>
+          <a:prstGeom prst="rect">
+            <a:avLst/>
+          </a:prstGeom>
+          <a:noFill/>
+        </p:spPr>
+        <p:txBody>
+          <a:bodyPr wrap="square">
+            <a:spAutoFit/>
+          </a:bodyPr>
+          <a:lstStyle/>
+          <a:p>
+            <a:pPr algn="ctr"/>
+            <a:r>
+              <a:rPr sz="900" b="1" i="0">
+                <a:solidFill>
+                  <a:srgbClr val="FFFFFF"/>
+                </a:solidFill>
+              </a:rPr>
+              <a:t>Predictions: Chickpea (39.5%)  &amp;  Watermelon (18%)</a:t>
+            </a:r>
+          </a:p>
+        </p:txBody>
+      </p:sp>
+      <p:sp>
+        <p:nvSpPr>
+          <p:cNvPr id="13" name="Rectangle 12"/>
+          <p:cNvSpPr/>
+          <p:nvPr/>
+        </p:nvSpPr>
+        <p:spPr>
+          <a:xfrm>
+            <a:off x="365760" y="4251960"/>
+            <a:ext cx="8412480" cy="685800"/>
+          </a:xfrm>
+          <a:prstGeom prst="rect">
+            <a:avLst/>
+          </a:prstGeom>
+          <a:solidFill>
+            <a:srgbClr val="FFFFFF"/>
+          </a:solidFill>
+          <a:ln>
+            <a:noFill/>
+          </a:ln>
+        </p:spPr>
+        <p:style>
+          <a:lnRef idx="1">
+            <a:schemeClr val="accent1"/>
+          </a:lnRef>
+          <a:fillRef idx="3">
+            <a:schemeClr val="accent1"/>
+          </a:fillRef>
+          <a:effectRef idx="2">
+            <a:schemeClr val="accent1"/>
+          </a:effectRef>
+          <a:fontRef idx="minor">
+            <a:schemeClr val="lt1"/>
+          </a:fontRef>
+        </p:style>
+        <p:txBody>
+          <a:bodyPr rtlCol="0" anchor="ctr"/>
+          <a:lstStyle/>
+          <a:p>
+            <a:pPr algn="ctr"/>
+          </a:p>
+        </p:txBody>
+      </p:sp>
+      <p:sp>
+        <p:nvSpPr>
+          <p:cNvPr id="14" name="Rectangle 13"/>
+          <p:cNvSpPr/>
+          <p:nvPr/>
+        </p:nvSpPr>
+        <p:spPr>
+          <a:xfrm>
+            <a:off x="365760" y="4251960"/>
+            <a:ext cx="8412480" cy="36576"/>
+          </a:xfrm>
+          <a:prstGeom prst="rect">
+            <a:avLst/>
+          </a:prstGeom>
+          <a:solidFill>
+            <a:srgbClr val="2C6E49"/>
+          </a:solidFill>
+          <a:ln>
+            <a:noFill/>
+          </a:ln>
+        </p:spPr>
+        <p:style>
+          <a:lnRef idx="1">
+            <a:schemeClr val="accent1"/>
+          </a:lnRef>
+          <a:fillRef idx="3">
+            <a:schemeClr val="accent1"/>
+          </a:fillRef>
+          <a:effectRef idx="2">
+            <a:schemeClr val="accent1"/>
+          </a:effectRef>
+          <a:fontRef idx="minor">
+            <a:schemeClr val="lt1"/>
+          </a:fontRef>
+        </p:style>
+        <p:txBody>
+          <a:bodyPr rtlCol="0" anchor="ctr"/>
+          <a:lstStyle/>
+          <a:p>
+            <a:pPr algn="ctr"/>
+          </a:p>
+        </p:txBody>
+      </p:sp>
+      <p:sp>
+        <p:nvSpPr>
+          <p:cNvPr id="15" name="Rectangle 14"/>
+          <p:cNvSpPr/>
+          <p:nvPr/>
+        </p:nvSpPr>
+        <p:spPr>
+          <a:xfrm>
+            <a:off x="594360" y="4325112"/>
+            <a:ext cx="1051560" cy="502920"/>
+          </a:xfrm>
+          <a:prstGeom prst="rect">
+            <a:avLst/>
+          </a:prstGeom>
+          <a:solidFill>
+            <a:srgbClr val="2C6E49"/>
+          </a:solidFill>
+          <a:ln>
+            <a:noFill/>
+          </a:ln>
+        </p:spPr>
+        <p:style>
+          <a:lnRef idx="1">
+            <a:schemeClr val="accent1"/>
+          </a:lnRef>
+          <a:fillRef idx="3">
+            <a:schemeClr val="accent1"/>
+          </a:fillRef>
+          <a:effectRef idx="2">
+            <a:schemeClr val="accent1"/>
+          </a:effectRef>
+          <a:fontRef idx="minor">
+            <a:schemeClr val="lt1"/>
+          </a:fontRef>
+        </p:style>
+        <p:txBody>
+          <a:bodyPr rtlCol="0" anchor="ctr"/>
+          <a:lstStyle/>
+          <a:p>
+            <a:pPr algn="ctr"/>
+          </a:p>
+        </p:txBody>
+      </p:sp>
+      <p:sp>
+        <p:nvSpPr>
+          <p:cNvPr id="16" name="TextBox 15"/>
+          <p:cNvSpPr txBox="1"/>
+          <p:nvPr/>
+        </p:nvSpPr>
+        <p:spPr>
+          <a:xfrm>
+            <a:off x="594360" y="4334256"/>
+            <a:ext cx="1051560" cy="246888"/>
+          </a:xfrm>
+          <a:prstGeom prst="rect">
+            <a:avLst/>
+          </a:prstGeom>
+          <a:noFill/>
+        </p:spPr>
+        <p:txBody>
+          <a:bodyPr wrap="square">
+            <a:spAutoFit/>
+          </a:bodyPr>
+          <a:lstStyle/>
+          <a:p>
+            <a:pPr algn="ctr"/>
+            <a:r>
+              <a:rPr sz="900" b="1" i="0">
+                <a:solidFill>
+                  <a:srgbClr val="FFFFFF"/>
+                </a:solidFill>
+              </a:rPr>
+              <a:t>Random Forest</a:t>
+            </a:r>
+          </a:p>
+        </p:txBody>
+      </p:sp>
+      <p:sp>
+        <p:nvSpPr>
+          <p:cNvPr id="17" name="TextBox 16"/>
+          <p:cNvSpPr txBox="1"/>
+          <p:nvPr/>
+        </p:nvSpPr>
+        <p:spPr>
+          <a:xfrm>
+            <a:off x="594360" y="4581144"/>
+            <a:ext cx="1051560" cy="219456"/>
+          </a:xfrm>
+          <a:prstGeom prst="rect">
+            <a:avLst/>
+          </a:prstGeom>
+          <a:noFill/>
+        </p:spPr>
+        <p:txBody>
+          <a:bodyPr wrap="square">
+            <a:spAutoFit/>
+          </a:bodyPr>
+          <a:lstStyle/>
+          <a:p>
+            <a:pPr algn="ctr"/>
+            <a:r>
+              <a:rPr sz="900" b="1" i="0">
+                <a:solidFill>
+                  <a:srgbClr val="FFFFFF"/>
+                </a:solidFill>
+              </a:rPr>
+              <a:t>99.39%</a:t>
+            </a:r>
+          </a:p>
+        </p:txBody>
+      </p:sp>
+      <p:sp>
+        <p:nvSpPr>
+          <p:cNvPr id="18" name="TextBox 17"/>
+          <p:cNvSpPr txBox="1"/>
+          <p:nvPr/>
+        </p:nvSpPr>
+        <p:spPr>
+          <a:xfrm>
+            <a:off x="1709928" y="4425696"/>
+            <a:ext cx="1463040" cy="256032"/>
+          </a:xfrm>
+          <a:prstGeom prst="rect">
+            <a:avLst/>
+          </a:prstGeom>
+          <a:noFill/>
+        </p:spPr>
+        <p:txBody>
+          <a:bodyPr wrap="square">
+            <a:spAutoFit/>
+          </a:bodyPr>
+          <a:lstStyle/>
+          <a:p>
+            <a:pPr algn="l"/>
+            <a:r>
+              <a:rPr sz="850" b="0" i="0">
+                <a:solidFill>
+                  <a:srgbClr val="64748B"/>
+                </a:solidFill>
+              </a:rPr>
+              <a:t>Deployed model accuracy from live app</a:t>
+            </a:r>
+          </a:p>
+        </p:txBody>
+      </p:sp>
+      <p:sp>
+        <p:nvSpPr>
+          <p:cNvPr id="19" name="Rectangle 18"/>
+          <p:cNvSpPr/>
+          <p:nvPr/>
+        </p:nvSpPr>
+        <p:spPr>
+          <a:xfrm>
+            <a:off x="3337560" y="4325112"/>
+            <a:ext cx="1051560" cy="502920"/>
+          </a:xfrm>
+          <a:prstGeom prst="rect">
+            <a:avLst/>
+          </a:prstGeom>
+          <a:solidFill>
+            <a:srgbClr val="4A9E6B"/>
+          </a:solidFill>
+          <a:ln>
+            <a:noFill/>
+          </a:ln>
+        </p:spPr>
+        <p:style>
+          <a:lnRef idx="1">
+            <a:schemeClr val="accent1"/>
+          </a:lnRef>
+          <a:fillRef idx="3">
+            <a:schemeClr val="accent1"/>
+          </a:fillRef>
+          <a:effectRef idx="2">
+            <a:schemeClr val="accent1"/>
+          </a:effectRef>
+          <a:fontRef idx="minor">
+            <a:schemeClr val="lt1"/>
+          </a:fontRef>
+        </p:style>
+        <p:txBody>
+          <a:bodyPr rtlCol="0" anchor="ctr"/>
+          <a:lstStyle/>
+          <a:p>
+            <a:pPr algn="ctr"/>
+          </a:p>
+        </p:txBody>
+      </p:sp>
+      <p:sp>
+        <p:nvSpPr>
+          <p:cNvPr id="20" name="TextBox 19"/>
+          <p:cNvSpPr txBox="1"/>
+          <p:nvPr/>
+        </p:nvSpPr>
+        <p:spPr>
+          <a:xfrm>
+            <a:off x="3337560" y="4334256"/>
+            <a:ext cx="1051560" cy="246888"/>
+          </a:xfrm>
+          <a:prstGeom prst="rect">
+            <a:avLst/>
+          </a:prstGeom>
+          <a:noFill/>
+        </p:spPr>
+        <p:txBody>
+          <a:bodyPr wrap="square">
+            <a:spAutoFit/>
+          </a:bodyPr>
+          <a:lstStyle/>
+          <a:p>
+            <a:pPr algn="ctr"/>
+            <a:r>
+              <a:rPr sz="900" b="1" i="0">
+                <a:solidFill>
+                  <a:srgbClr val="FFFFFF"/>
+                </a:solidFill>
+              </a:rPr>
+              <a:t>KNN</a:t>
+            </a:r>
+          </a:p>
+        </p:txBody>
+      </p:sp>
+      <p:sp>
+        <p:nvSpPr>
+          <p:cNvPr id="21" name="TextBox 20"/>
+          <p:cNvSpPr txBox="1"/>
+          <p:nvPr/>
+        </p:nvSpPr>
+        <p:spPr>
+          <a:xfrm>
+            <a:off x="3337560" y="4581144"/>
+            <a:ext cx="1051560" cy="219456"/>
+          </a:xfrm>
+          <a:prstGeom prst="rect">
+            <a:avLst/>
+          </a:prstGeom>
+          <a:noFill/>
+        </p:spPr>
+        <p:txBody>
+          <a:bodyPr wrap="square">
+            <a:spAutoFit/>
+          </a:bodyPr>
+          <a:lstStyle/>
+          <a:p>
+            <a:pPr algn="ctr"/>
+            <a:r>
+              <a:rPr sz="900" b="1" i="0">
+                <a:solidFill>
+                  <a:srgbClr val="FFFFFF"/>
+                </a:solidFill>
+              </a:rPr>
+              <a:t>97.58%</a:t>
+            </a:r>
+          </a:p>
+        </p:txBody>
+      </p:sp>
+      <p:sp>
+        <p:nvSpPr>
+          <p:cNvPr id="22" name="TextBox 21"/>
+          <p:cNvSpPr txBox="1"/>
+          <p:nvPr/>
+        </p:nvSpPr>
+        <p:spPr>
+          <a:xfrm>
+            <a:off x="4453128" y="4425696"/>
+            <a:ext cx="1463040" cy="256032"/>
+          </a:xfrm>
+          <a:prstGeom prst="rect">
+            <a:avLst/>
+          </a:prstGeom>
+          <a:noFill/>
+        </p:spPr>
+        <p:txBody>
+          <a:bodyPr wrap="square">
+            <a:spAutoFit/>
+          </a:bodyPr>
+          <a:lstStyle/>
+          <a:p>
+            <a:pPr algn="l"/>
+            <a:r>
+              <a:rPr sz="850" b="0" i="0">
+                <a:solidFill>
+                  <a:srgbClr val="64748B"/>
+                </a:solidFill>
+              </a:rPr>
+              <a:t>Deployed model accuracy from live app</a:t>
+            </a:r>
+          </a:p>
+        </p:txBody>
+      </p:sp>
+      <p:sp>
+        <p:nvSpPr>
+          <p:cNvPr id="23" name="Rectangle 22"/>
+          <p:cNvSpPr/>
+          <p:nvPr/>
+        </p:nvSpPr>
+        <p:spPr>
+          <a:xfrm>
+            <a:off x="6080760" y="4325112"/>
+            <a:ext cx="1051560" cy="502920"/>
+          </a:xfrm>
+          <a:prstGeom prst="rect">
+            <a:avLst/>
+          </a:prstGeom>
+          <a:solidFill>
+            <a:srgbClr val="F4A261"/>
+          </a:solidFill>
+          <a:ln>
+            <a:noFill/>
+          </a:ln>
+        </p:spPr>
+        <p:style>
+          <a:lnRef idx="1">
+            <a:schemeClr val="accent1"/>
+          </a:lnRef>
+          <a:fillRef idx="3">
+            <a:schemeClr val="accent1"/>
+          </a:fillRef>
+          <a:effectRef idx="2">
+            <a:schemeClr val="accent1"/>
+          </a:effectRef>
+          <a:fontRef idx="minor">
+            <a:schemeClr val="lt1"/>
+          </a:fontRef>
+        </p:style>
+        <p:txBody>
+          <a:bodyPr rtlCol="0" anchor="ctr"/>
+          <a:lstStyle/>
+          <a:p>
+            <a:pPr algn="ctr"/>
+          </a:p>
+        </p:txBody>
+      </p:sp>
+      <p:sp>
+        <p:nvSpPr>
+          <p:cNvPr id="24" name="TextBox 23"/>
+          <p:cNvSpPr txBox="1"/>
+          <p:nvPr/>
+        </p:nvSpPr>
+        <p:spPr>
+          <a:xfrm>
+            <a:off x="6080760" y="4334256"/>
+            <a:ext cx="1051560" cy="246888"/>
+          </a:xfrm>
+          <a:prstGeom prst="rect">
+            <a:avLst/>
+          </a:prstGeom>
+          <a:noFill/>
+        </p:spPr>
+        <p:txBody>
+          <a:bodyPr wrap="square">
+            <a:spAutoFit/>
+          </a:bodyPr>
+          <a:lstStyle/>
+          <a:p>
+            <a:pPr algn="ctr"/>
+            <a:r>
+              <a:rPr sz="900" b="1" i="0">
+                <a:solidFill>
+                  <a:srgbClr val="FFFFFF"/>
+                </a:solidFill>
+              </a:rPr>
+              <a:t>Decision Tree</a:t>
+            </a:r>
+          </a:p>
+        </p:txBody>
+      </p:sp>
+      <p:sp>
+        <p:nvSpPr>
+          <p:cNvPr id="25" name="TextBox 24"/>
+          <p:cNvSpPr txBox="1"/>
+          <p:nvPr/>
+        </p:nvSpPr>
+        <p:spPr>
+          <a:xfrm>
+            <a:off x="6080760" y="4581144"/>
+            <a:ext cx="1051560" cy="219456"/>
+          </a:xfrm>
+          <a:prstGeom prst="rect">
+            <a:avLst/>
+          </a:prstGeom>
+          <a:noFill/>
+        </p:spPr>
+        <p:txBody>
+          <a:bodyPr wrap="square">
+            <a:spAutoFit/>
+          </a:bodyPr>
+          <a:lstStyle/>
+          <a:p>
+            <a:pPr algn="ctr"/>
+            <a:r>
+              <a:rPr sz="900" b="1" i="0">
+                <a:solidFill>
+                  <a:srgbClr val="FFFFFF"/>
+                </a:solidFill>
+              </a:rPr>
+              <a:t>98.18%</a:t>
+            </a:r>
+          </a:p>
+        </p:txBody>
+      </p:sp>
+      <p:sp>
+        <p:nvSpPr>
+          <p:cNvPr id="26" name="TextBox 25"/>
+          <p:cNvSpPr txBox="1"/>
+          <p:nvPr/>
+        </p:nvSpPr>
+        <p:spPr>
+          <a:xfrm>
+            <a:off x="7196328" y="4425696"/>
+            <a:ext cx="1463040" cy="256032"/>
+          </a:xfrm>
+          <a:prstGeom prst="rect">
+            <a:avLst/>
+          </a:prstGeom>
+          <a:noFill/>
+        </p:spPr>
+        <p:txBody>
+          <a:bodyPr wrap="square">
+            <a:spAutoFit/>
+          </a:bodyPr>
+          <a:lstStyle/>
+          <a:p>
+            <a:pPr algn="l"/>
+            <a:r>
+              <a:rPr sz="850" b="0" i="0">
+                <a:solidFill>
+                  <a:srgbClr val="64748B"/>
+                </a:solidFill>
+              </a:rPr>
+              <a:t>Deployed model accuracy from live app</a:t>
+            </a:r>
           </a:p>
         </p:txBody>
       </p:sp>

</xml_diff>